<commit_message>
Rebuild culture slide to match the original wheel composition
Replace the earlier hub-and-spoke restructure with a layout that mirrors
the original PDF's actual composition: one wheel with a curved title arc,
5 pillar wedges each carrying its badge/icon/title/subhead/bullets/mindset
directly (not split into external cards), a center core-purpose medallion,
an inner tagline ring, and a curved values line, all in the Valletta
black/red/white system with the confirmed Valletta+SOC logo lockup above
the wheel. Content is unchanged from the source PDF; geometry was verified
programmatically (min/max distance from center per text block) so nothing
clips or overlaps at any wedge position.

Co-Authored-By: Claude Sonnet 5 <noreply@anthropic.com>
Claude-Session: https://claude.ai/code/session_01MW2NfkMi5UUsKy9x4vEp7k
</commit_message>
<xml_diff>
--- a/exports/valletta_culture_slide.pptx
+++ b/exports/valletta_culture_slide.pptx
@@ -7,7 +7,7 @@
   <p:sldIdLst>
     <p:sldId id="256" r:id="rId7"/>
   </p:sldIdLst>
-  <p:sldSz cx="7315200" cy="7315200" type="screen4x3"/>
+  <p:sldSz cx="7315200" cy="8953500" type="screen4x3"/>
   <p:notesSz cx="6858000" cy="9144000"/>
   <p:defaultTextStyle>
     <a:defPPr>
@@ -3105,7 +3105,7 @@
         <p:spPr>
           <a:xfrm>
             <a:off x="0" y="0"/>
-            <a:ext cx="7315200" cy="7315200"/>
+            <a:ext cx="7315200" cy="8953500"/>
           </a:xfrm>
           <a:prstGeom prst="rect">
             <a:avLst/>

</xml_diff>

<commit_message>
Replace wheel infographic with a clean editorial layout
Drop the circular wheel entirely per feedback that it was cramped and
hard to read (tiny type, wedge-divider lines crossing text). Rebuild as
a flowing, generously-spaced document: masthead with the Valletta+SOC
logo, a hero headline, a full-bleed core-purpose band, and the 5 pillars
as clean rows (number, icon, title, subhead, bullets, mindset pull-quote)
in real body-copy type sizes. Same Valletta black/red/white system,
same unedited source content. Responsive from desktop to phone width,
and paginates cleanly as a 4-page US Letter PDF.

Co-Authored-By: Claude Sonnet 5 <noreply@anthropic.com>
Claude-Session: https://claude.ai/code/session_01MW2NfkMi5UUsKy9x4vEp7k
</commit_message>
<xml_diff>
--- a/exports/valletta_culture_slide.pptx
+++ b/exports/valletta_culture_slide.pptx
@@ -7,7 +7,7 @@
   <p:sldIdLst>
     <p:sldId id="256" r:id="rId7"/>
   </p:sldIdLst>
-  <p:sldSz cx="7315200" cy="8953500" type="screen4x3"/>
+  <p:sldSz cx="9144000" cy="25740360" type="screen4x3"/>
   <p:notesSz cx="6858000" cy="9144000"/>
   <p:defaultTextStyle>
     <a:defPPr>
@@ -3105,7 +3105,7 @@
         <p:spPr>
           <a:xfrm>
             <a:off x="0" y="0"/>
-            <a:ext cx="7315200" cy="8953500"/>
+            <a:ext cx="9144000" cy="25740360"/>
           </a:xfrm>
           <a:prstGeom prst="rect">
             <a:avLst/>

</xml_diff>

<commit_message>
Rebuild culture slide as a single one-page graphic
Replace the scrolling document with a single 2000x950 landscape
one-pager per feedback that they want an impactful graphic, not a long
page: masthead, a full-bleed core-purpose band, the 5 pillars as five
columns side by side (number, icon, title, subhead, bullets, mindset
quote), and the values/closing banner — all in one view, no scrolling.
Same unedited source content and Valletta black/red/white system.

Co-Authored-By: Claude Sonnet 5 <noreply@anthropic.com>
Claude-Session: https://claude.ai/code/session_01MW2NfkMi5UUsKy9x4vEp7k
</commit_message>
<xml_diff>
--- a/exports/valletta_culture_slide.pptx
+++ b/exports/valletta_culture_slide.pptx
@@ -7,7 +7,7 @@
   <p:sldIdLst>
     <p:sldId id="256" r:id="rId7"/>
   </p:sldIdLst>
-  <p:sldSz cx="9144000" cy="25740360" type="screen4x3"/>
+  <p:sldSz cx="12191695" cy="5791055" type="screen4x3"/>
   <p:notesSz cx="6858000" cy="9144000"/>
   <p:defaultTextStyle>
     <a:defPPr>
@@ -3105,7 +3105,7 @@
         <p:spPr>
           <a:xfrm>
             <a:off x="0" y="0"/>
-            <a:ext cx="9144000" cy="25740360"/>
+            <a:ext cx="12191695" cy="5791055"/>
           </a:xfrm>
           <a:prstGeom prst="rect">
             <a:avLst/>

</xml_diff>